<commit_message>
Update Statistics module finished
Update of the Statistics module is now finished. It includes:
- non-parametric stat with filedtrip
- option to save 1-p or p
</commit_message>
<xml_diff>
--- a/Manuels/picture_EEGpal_manuals.pptx
+++ b/Manuels/picture_EEGpal_manuals.pptx
@@ -319,7 +319,7 @@
           <a:p>
             <a:fld id="{AE28F081-F961-4F1D-B0FD-EEC618487470}" type="datetimeFigureOut">
               <a:rPr lang="en-US" smtClean="0"/>
-              <a:t>9/5/2026</a:t>
+              <a:t>9/13/2026</a:t>
             </a:fld>
             <a:endParaRPr lang="en-US"/>
           </a:p>
@@ -851,7 +851,7 @@
           <a:p>
             <a:fld id="{BCB0654D-2F9E-40DC-B910-8F58A623289D}" type="datetimeFigureOut">
               <a:rPr lang="fr-CH" smtClean="0"/>
-              <a:t>05.09.2026</a:t>
+              <a:t>13.09.2026</a:t>
             </a:fld>
             <a:endParaRPr lang="fr-CH"/>
           </a:p>
@@ -1021,7 +1021,7 @@
           <a:p>
             <a:fld id="{BCB0654D-2F9E-40DC-B910-8F58A623289D}" type="datetimeFigureOut">
               <a:rPr lang="fr-CH" smtClean="0"/>
-              <a:t>05.09.2026</a:t>
+              <a:t>13.09.2026</a:t>
             </a:fld>
             <a:endParaRPr lang="fr-CH"/>
           </a:p>
@@ -1201,7 +1201,7 @@
           <a:p>
             <a:fld id="{BCB0654D-2F9E-40DC-B910-8F58A623289D}" type="datetimeFigureOut">
               <a:rPr lang="fr-CH" smtClean="0"/>
-              <a:t>05.09.2026</a:t>
+              <a:t>13.09.2026</a:t>
             </a:fld>
             <a:endParaRPr lang="fr-CH"/>
           </a:p>
@@ -1371,7 +1371,7 @@
           <a:p>
             <a:fld id="{BCB0654D-2F9E-40DC-B910-8F58A623289D}" type="datetimeFigureOut">
               <a:rPr lang="fr-CH" smtClean="0"/>
-              <a:t>05.09.2026</a:t>
+              <a:t>13.09.2026</a:t>
             </a:fld>
             <a:endParaRPr lang="fr-CH"/>
           </a:p>
@@ -1617,7 +1617,7 @@
           <a:p>
             <a:fld id="{BCB0654D-2F9E-40DC-B910-8F58A623289D}" type="datetimeFigureOut">
               <a:rPr lang="fr-CH" smtClean="0"/>
-              <a:t>05.09.2026</a:t>
+              <a:t>13.09.2026</a:t>
             </a:fld>
             <a:endParaRPr lang="fr-CH"/>
           </a:p>
@@ -1905,7 +1905,7 @@
           <a:p>
             <a:fld id="{BCB0654D-2F9E-40DC-B910-8F58A623289D}" type="datetimeFigureOut">
               <a:rPr lang="fr-CH" smtClean="0"/>
-              <a:t>05.09.2026</a:t>
+              <a:t>13.09.2026</a:t>
             </a:fld>
             <a:endParaRPr lang="fr-CH"/>
           </a:p>
@@ -2327,7 +2327,7 @@
           <a:p>
             <a:fld id="{BCB0654D-2F9E-40DC-B910-8F58A623289D}" type="datetimeFigureOut">
               <a:rPr lang="fr-CH" smtClean="0"/>
-              <a:t>05.09.2026</a:t>
+              <a:t>13.09.2026</a:t>
             </a:fld>
             <a:endParaRPr lang="fr-CH"/>
           </a:p>
@@ -2445,7 +2445,7 @@
           <a:p>
             <a:fld id="{BCB0654D-2F9E-40DC-B910-8F58A623289D}" type="datetimeFigureOut">
               <a:rPr lang="fr-CH" smtClean="0"/>
-              <a:t>05.09.2026</a:t>
+              <a:t>13.09.2026</a:t>
             </a:fld>
             <a:endParaRPr lang="fr-CH"/>
           </a:p>
@@ -2540,7 +2540,7 @@
           <a:p>
             <a:fld id="{BCB0654D-2F9E-40DC-B910-8F58A623289D}" type="datetimeFigureOut">
               <a:rPr lang="fr-CH" smtClean="0"/>
-              <a:t>05.09.2026</a:t>
+              <a:t>13.09.2026</a:t>
             </a:fld>
             <a:endParaRPr lang="fr-CH"/>
           </a:p>
@@ -2817,7 +2817,7 @@
           <a:p>
             <a:fld id="{BCB0654D-2F9E-40DC-B910-8F58A623289D}" type="datetimeFigureOut">
               <a:rPr lang="fr-CH" smtClean="0"/>
-              <a:t>05.09.2026</a:t>
+              <a:t>13.09.2026</a:t>
             </a:fld>
             <a:endParaRPr lang="fr-CH"/>
           </a:p>
@@ -3070,7 +3070,7 @@
           <a:p>
             <a:fld id="{BCB0654D-2F9E-40DC-B910-8F58A623289D}" type="datetimeFigureOut">
               <a:rPr lang="fr-CH" smtClean="0"/>
-              <a:t>05.09.2026</a:t>
+              <a:t>13.09.2026</a:t>
             </a:fld>
             <a:endParaRPr lang="fr-CH"/>
           </a:p>
@@ -3283,7 +3283,7 @@
           <a:p>
             <a:fld id="{BCB0654D-2F9E-40DC-B910-8F58A623289D}" type="datetimeFigureOut">
               <a:rPr lang="fr-CH" smtClean="0"/>
-              <a:t>05.09.2026</a:t>
+              <a:t>13.09.2026</a:t>
             </a:fld>
             <a:endParaRPr lang="fr-CH"/>
           </a:p>
@@ -13657,7 +13657,7 @@
         </p:blipFill>
         <p:spPr>
           <a:xfrm>
-            <a:off x="1260629" y="1385288"/>
+            <a:off x="1241579" y="142875"/>
             <a:ext cx="6454947" cy="3148612"/>
           </a:xfrm>
           <a:prstGeom prst="rect">
@@ -13679,7 +13679,7 @@
         </p:nvSpPr>
         <p:spPr>
           <a:xfrm>
-            <a:off x="2588055" y="2002410"/>
+            <a:off x="2569005" y="759997"/>
             <a:ext cx="301686" cy="369332"/>
           </a:xfrm>
           <a:prstGeom prst="rect">
@@ -13714,7 +13714,7 @@
         </p:nvSpPr>
         <p:spPr>
           <a:xfrm>
-            <a:off x="2531402" y="2371742"/>
+            <a:off x="2512352" y="1129329"/>
             <a:ext cx="301686" cy="369332"/>
           </a:xfrm>
           <a:prstGeom prst="rect">
@@ -13749,7 +13749,7 @@
         </p:nvSpPr>
         <p:spPr>
           <a:xfrm>
-            <a:off x="2652252" y="3002516"/>
+            <a:off x="2633202" y="1760103"/>
             <a:ext cx="301686" cy="369332"/>
           </a:xfrm>
           <a:prstGeom prst="rect">
@@ -13784,7 +13784,7 @@
         </p:nvSpPr>
         <p:spPr>
           <a:xfrm>
-            <a:off x="2214968" y="3312493"/>
+            <a:off x="2195918" y="2070080"/>
             <a:ext cx="301686" cy="369332"/>
           </a:xfrm>
           <a:prstGeom prst="rect">
@@ -13819,7 +13819,7 @@
         </p:nvSpPr>
         <p:spPr>
           <a:xfrm>
-            <a:off x="3072678" y="3851379"/>
+            <a:off x="3053628" y="2608966"/>
             <a:ext cx="301686" cy="369332"/>
           </a:xfrm>
           <a:prstGeom prst="rect">
@@ -13854,7 +13854,7 @@
         </p:nvSpPr>
         <p:spPr>
           <a:xfrm>
-            <a:off x="5100209" y="1924066"/>
+            <a:off x="5081159" y="681653"/>
             <a:ext cx="301686" cy="369332"/>
           </a:xfrm>
           <a:prstGeom prst="rect">
@@ -13889,7 +13889,7 @@
         </p:nvSpPr>
         <p:spPr>
           <a:xfrm>
-            <a:off x="5850692" y="2609314"/>
+            <a:off x="5831642" y="1366901"/>
             <a:ext cx="301686" cy="369332"/>
           </a:xfrm>
           <a:prstGeom prst="rect">
@@ -13924,7 +13924,7 @@
         </p:nvSpPr>
         <p:spPr>
           <a:xfrm>
-            <a:off x="4647246" y="2861159"/>
+            <a:off x="4628196" y="1618746"/>
             <a:ext cx="301686" cy="369332"/>
           </a:xfrm>
           <a:prstGeom prst="rect">
@@ -13959,7 +13959,7 @@
         </p:nvSpPr>
         <p:spPr>
           <a:xfrm>
-            <a:off x="5549006" y="3369675"/>
+            <a:off x="5529956" y="2127262"/>
             <a:ext cx="301686" cy="369332"/>
           </a:xfrm>
           <a:prstGeom prst="rect">
@@ -13994,7 +13994,7 @@
         </p:nvSpPr>
         <p:spPr>
           <a:xfrm>
-            <a:off x="5377386" y="3656083"/>
+            <a:off x="5358336" y="2413670"/>
             <a:ext cx="418704" cy="369332"/>
           </a:xfrm>
           <a:prstGeom prst="rect">
@@ -14029,7 +14029,7 @@
         </p:nvSpPr>
         <p:spPr>
           <a:xfrm>
-            <a:off x="5388331" y="3872636"/>
+            <a:off x="5369281" y="2630223"/>
             <a:ext cx="418704" cy="369332"/>
           </a:xfrm>
           <a:prstGeom prst="rect">
@@ -14068,7 +14068,7 @@
         </p:nvSpPr>
         <p:spPr>
           <a:xfrm>
-            <a:off x="7188856" y="1872386"/>
+            <a:off x="7543827" y="445655"/>
             <a:ext cx="418704" cy="369332"/>
           </a:xfrm>
           <a:prstGeom prst="rect">
@@ -14088,7 +14088,7 @@
             </a:r>
             <a:r>
               <a:rPr lang="fr-CH" dirty="0"/>
-              <a:t>2</a:t>
+              <a:t>7</a:t>
             </a:r>
           </a:p>
         </p:txBody>
@@ -14107,7 +14107,7 @@
         </p:nvSpPr>
         <p:spPr>
           <a:xfrm>
-            <a:off x="7284108" y="3094487"/>
+            <a:off x="7265058" y="1852074"/>
             <a:ext cx="418704" cy="369332"/>
           </a:xfrm>
           <a:prstGeom prst="rect">
@@ -14127,7 +14127,7 @@
             </a:r>
             <a:r>
               <a:rPr lang="fr-CH" dirty="0"/>
-              <a:t>3</a:t>
+              <a:t>9</a:t>
             </a:r>
           </a:p>
         </p:txBody>
@@ -14146,7 +14146,7 @@
         </p:nvSpPr>
         <p:spPr>
           <a:xfrm>
-            <a:off x="7317602" y="3554341"/>
+            <a:off x="7298552" y="2311928"/>
             <a:ext cx="418704" cy="369332"/>
           </a:xfrm>
           <a:prstGeom prst="rect">
@@ -14162,12 +14162,9 @@
           <a:p>
             <a:r>
               <a:rPr lang="fr-FR" dirty="0"/>
-              <a:t>1</a:t>
-            </a:r>
-            <a:r>
-              <a:rPr lang="fr-CH" dirty="0"/>
-              <a:t>4</a:t>
-            </a:r>
+              <a:t>20</a:t>
+            </a:r>
+            <a:endParaRPr lang="fr-CH" dirty="0"/>
           </a:p>
         </p:txBody>
       </p:sp>
@@ -14193,7 +14190,7 @@
         </p:blipFill>
         <p:spPr>
           <a:xfrm>
-            <a:off x="6217920" y="4091785"/>
+            <a:off x="6198870" y="2849372"/>
             <a:ext cx="1495448" cy="400420"/>
           </a:xfrm>
           <a:prstGeom prst="rect">
@@ -14215,7 +14212,74 @@
         </p:nvSpPr>
         <p:spPr>
           <a:xfrm>
-            <a:off x="6484104" y="3959055"/>
+            <a:off x="6465054" y="2716642"/>
+            <a:ext cx="418704" cy="369332"/>
+          </a:xfrm>
+          <a:prstGeom prst="rect">
+            <a:avLst/>
+          </a:prstGeom>
+          <a:noFill/>
+        </p:spPr>
+        <p:txBody>
+          <a:bodyPr wrap="none" rtlCol="0">
+            <a:spAutoFit/>
+          </a:bodyPr>
+          <a:lstStyle/>
+          <a:p>
+            <a:r>
+              <a:rPr lang="fr-FR" dirty="0"/>
+              <a:t>21</a:t>
+            </a:r>
+            <a:endParaRPr lang="fr-CH" dirty="0"/>
+          </a:p>
+        </p:txBody>
+      </p:sp>
+      <p:pic>
+        <p:nvPicPr>
+          <p:cNvPr id="19" name="Picture 18">
+            <a:extLst>
+              <a:ext uri="{FF2B5EF4-FFF2-40B4-BE49-F238E27FC236}">
+                <a16:creationId xmlns:a16="http://schemas.microsoft.com/office/drawing/2014/main" id="{50B04524-2CB1-F54F-8B65-EDDB1D33AE69}"/>
+              </a:ext>
+            </a:extLst>
+          </p:cNvPr>
+          <p:cNvPicPr>
+            <a:picLocks noChangeAspect="1"/>
+          </p:cNvPicPr>
+          <p:nvPr/>
+        </p:nvPicPr>
+        <p:blipFill>
+          <a:blip r:embed="rId4"/>
+          <a:srcRect l="81082" t="21389" b="73017"/>
+          <a:stretch>
+            <a:fillRect/>
+          </a:stretch>
+        </p:blipFill>
+        <p:spPr>
+          <a:xfrm>
+            <a:off x="6465054" y="814987"/>
+            <a:ext cx="1218708" cy="175793"/>
+          </a:xfrm>
+          <a:prstGeom prst="rect">
+            <a:avLst/>
+          </a:prstGeom>
+        </p:spPr>
+      </p:pic>
+      <p:sp>
+        <p:nvSpPr>
+          <p:cNvPr id="20" name="ZoneTexte 14">
+            <a:extLst>
+              <a:ext uri="{FF2B5EF4-FFF2-40B4-BE49-F238E27FC236}">
+                <a16:creationId xmlns:a16="http://schemas.microsoft.com/office/drawing/2014/main" id="{3864A1F2-E830-9202-3417-8F2A5838201E}"/>
+              </a:ext>
+            </a:extLst>
+          </p:cNvPr>
+          <p:cNvSpPr txBox="1"/>
+          <p:nvPr/>
+        </p:nvSpPr>
+        <p:spPr>
+          <a:xfrm>
+            <a:off x="7543827" y="727077"/>
             <a:ext cx="418704" cy="369332"/>
           </a:xfrm>
           <a:prstGeom prst="rect">
@@ -14235,7 +14299,675 @@
             </a:r>
             <a:r>
               <a:rPr lang="fr-CH" dirty="0"/>
-              <a:t>5</a:t>
+              <a:t>8</a:t>
+            </a:r>
+          </a:p>
+        </p:txBody>
+      </p:sp>
+      <p:pic>
+        <p:nvPicPr>
+          <p:cNvPr id="23" name="Picture 22">
+            <a:extLst>
+              <a:ext uri="{FF2B5EF4-FFF2-40B4-BE49-F238E27FC236}">
+                <a16:creationId xmlns:a16="http://schemas.microsoft.com/office/drawing/2014/main" id="{BE791972-5B20-CC70-1B4E-70DFA690AECA}"/>
+              </a:ext>
+            </a:extLst>
+          </p:cNvPr>
+          <p:cNvPicPr>
+            <a:picLocks noChangeAspect="1"/>
+          </p:cNvPicPr>
+          <p:nvPr/>
+        </p:nvPicPr>
+        <p:blipFill>
+          <a:blip r:embed="rId5"/>
+          <a:srcRect l="36242" t="6891" r="25632"/>
+          <a:stretch>
+            <a:fillRect/>
+          </a:stretch>
+        </p:blipFill>
+        <p:spPr>
+          <a:xfrm>
+            <a:off x="3589077" y="3463949"/>
+            <a:ext cx="2456123" cy="2925833"/>
+          </a:xfrm>
+          <a:prstGeom prst="rect">
+            <a:avLst/>
+          </a:prstGeom>
+        </p:spPr>
+      </p:pic>
+      <p:sp>
+        <p:nvSpPr>
+          <p:cNvPr id="24" name="TextBox 23">
+            <a:extLst>
+              <a:ext uri="{FF2B5EF4-FFF2-40B4-BE49-F238E27FC236}">
+                <a16:creationId xmlns:a16="http://schemas.microsoft.com/office/drawing/2014/main" id="{C220FCAF-E922-FFFA-5F64-EEDD05CAE943}"/>
+              </a:ext>
+            </a:extLst>
+          </p:cNvPr>
+          <p:cNvSpPr txBox="1"/>
+          <p:nvPr/>
+        </p:nvSpPr>
+        <p:spPr>
+          <a:xfrm>
+            <a:off x="1238559" y="4742092"/>
+            <a:ext cx="2079608" cy="369332"/>
+          </a:xfrm>
+          <a:prstGeom prst="rect">
+            <a:avLst/>
+          </a:prstGeom>
+          <a:noFill/>
+        </p:spPr>
+        <p:txBody>
+          <a:bodyPr wrap="none" rtlCol="0">
+            <a:spAutoFit/>
+          </a:bodyPr>
+          <a:lstStyle/>
+          <a:p>
+            <a:r>
+              <a:rPr lang="fr-FR" dirty="0"/>
+              <a:t>Non-</a:t>
+            </a:r>
+            <a:r>
+              <a:rPr lang="fr-FR" dirty="0" err="1"/>
+              <a:t>parametric</a:t>
+            </a:r>
+            <a:r>
+              <a:rPr lang="fr-FR" dirty="0"/>
+              <a:t> test</a:t>
+            </a:r>
+            <a:endParaRPr lang="LID4096" dirty="0"/>
+          </a:p>
+        </p:txBody>
+      </p:sp>
+      <p:sp>
+        <p:nvSpPr>
+          <p:cNvPr id="26" name="TextBox 25">
+            <a:extLst>
+              <a:ext uri="{FF2B5EF4-FFF2-40B4-BE49-F238E27FC236}">
+                <a16:creationId xmlns:a16="http://schemas.microsoft.com/office/drawing/2014/main" id="{D7323D43-1183-AAA3-9189-489EE628AE2E}"/>
+              </a:ext>
+            </a:extLst>
+          </p:cNvPr>
+          <p:cNvSpPr txBox="1"/>
+          <p:nvPr/>
+        </p:nvSpPr>
+        <p:spPr>
+          <a:xfrm>
+            <a:off x="-24623" y="1528908"/>
+            <a:ext cx="1266202" cy="646331"/>
+          </a:xfrm>
+          <a:prstGeom prst="rect">
+            <a:avLst/>
+          </a:prstGeom>
+          <a:noFill/>
+        </p:spPr>
+        <p:txBody>
+          <a:bodyPr wrap="square" rtlCol="0">
+            <a:spAutoFit/>
+          </a:bodyPr>
+          <a:lstStyle/>
+          <a:p>
+            <a:r>
+              <a:rPr lang="fr-FR" dirty="0" err="1"/>
+              <a:t>Parametric</a:t>
+            </a:r>
+            <a:r>
+              <a:rPr lang="fr-FR" dirty="0"/>
+              <a:t> test</a:t>
+            </a:r>
+            <a:endParaRPr lang="LID4096" dirty="0"/>
+          </a:p>
+        </p:txBody>
+      </p:sp>
+      <p:sp>
+        <p:nvSpPr>
+          <p:cNvPr id="28" name="ZoneTexte 11">
+            <a:extLst>
+              <a:ext uri="{FF2B5EF4-FFF2-40B4-BE49-F238E27FC236}">
+                <a16:creationId xmlns:a16="http://schemas.microsoft.com/office/drawing/2014/main" id="{B4417EAB-5B76-3670-4199-4D14206A4B35}"/>
+              </a:ext>
+            </a:extLst>
+          </p:cNvPr>
+          <p:cNvSpPr txBox="1"/>
+          <p:nvPr/>
+        </p:nvSpPr>
+        <p:spPr>
+          <a:xfrm>
+            <a:off x="3328056" y="4926758"/>
+            <a:ext cx="418704" cy="369332"/>
+          </a:xfrm>
+          <a:prstGeom prst="rect">
+            <a:avLst/>
+          </a:prstGeom>
+          <a:noFill/>
+        </p:spPr>
+        <p:txBody>
+          <a:bodyPr wrap="none" rtlCol="0">
+            <a:spAutoFit/>
+          </a:bodyPr>
+          <a:lstStyle/>
+          <a:p>
+            <a:r>
+              <a:rPr lang="fr-CH" dirty="0"/>
+              <a:t>13</a:t>
+            </a:r>
+          </a:p>
+        </p:txBody>
+      </p:sp>
+      <p:sp>
+        <p:nvSpPr>
+          <p:cNvPr id="29" name="ZoneTexte 11">
+            <a:extLst>
+              <a:ext uri="{FF2B5EF4-FFF2-40B4-BE49-F238E27FC236}">
+                <a16:creationId xmlns:a16="http://schemas.microsoft.com/office/drawing/2014/main" id="{9DD0CC4B-7B9E-4776-9689-40A6B68909BF}"/>
+              </a:ext>
+            </a:extLst>
+          </p:cNvPr>
+          <p:cNvSpPr txBox="1"/>
+          <p:nvPr/>
+        </p:nvSpPr>
+        <p:spPr>
+          <a:xfrm>
+            <a:off x="5887517" y="4926758"/>
+            <a:ext cx="418704" cy="369332"/>
+          </a:xfrm>
+          <a:prstGeom prst="rect">
+            <a:avLst/>
+          </a:prstGeom>
+          <a:noFill/>
+        </p:spPr>
+        <p:txBody>
+          <a:bodyPr wrap="none" rtlCol="0">
+            <a:spAutoFit/>
+          </a:bodyPr>
+          <a:lstStyle/>
+          <a:p>
+            <a:r>
+              <a:rPr lang="fr-CH" dirty="0"/>
+              <a:t>14</a:t>
+            </a:r>
+          </a:p>
+        </p:txBody>
+      </p:sp>
+      <p:sp>
+        <p:nvSpPr>
+          <p:cNvPr id="31" name="ZoneTexte 11">
+            <a:extLst>
+              <a:ext uri="{FF2B5EF4-FFF2-40B4-BE49-F238E27FC236}">
+                <a16:creationId xmlns:a16="http://schemas.microsoft.com/office/drawing/2014/main" id="{0B6F20C0-5144-1173-77B4-9B9CC8B7C317}"/>
+              </a:ext>
+            </a:extLst>
+          </p:cNvPr>
+          <p:cNvSpPr txBox="1"/>
+          <p:nvPr/>
+        </p:nvSpPr>
+        <p:spPr>
+          <a:xfrm>
+            <a:off x="5511209" y="5149714"/>
+            <a:ext cx="418704" cy="369332"/>
+          </a:xfrm>
+          <a:prstGeom prst="rect">
+            <a:avLst/>
+          </a:prstGeom>
+          <a:noFill/>
+        </p:spPr>
+        <p:txBody>
+          <a:bodyPr wrap="none" rtlCol="0">
+            <a:spAutoFit/>
+          </a:bodyPr>
+          <a:lstStyle/>
+          <a:p>
+            <a:r>
+              <a:rPr lang="fr-CH" dirty="0"/>
+              <a:t>15</a:t>
+            </a:r>
+          </a:p>
+        </p:txBody>
+      </p:sp>
+      <p:sp>
+        <p:nvSpPr>
+          <p:cNvPr id="32" name="ZoneTexte 11">
+            <a:extLst>
+              <a:ext uri="{FF2B5EF4-FFF2-40B4-BE49-F238E27FC236}">
+                <a16:creationId xmlns:a16="http://schemas.microsoft.com/office/drawing/2014/main" id="{09D44393-7E38-67A9-057D-FB5C87802BC1}"/>
+              </a:ext>
+            </a:extLst>
+          </p:cNvPr>
+          <p:cNvSpPr txBox="1"/>
+          <p:nvPr/>
+        </p:nvSpPr>
+        <p:spPr>
+          <a:xfrm>
+            <a:off x="6002320" y="5334380"/>
+            <a:ext cx="418704" cy="369332"/>
+          </a:xfrm>
+          <a:prstGeom prst="rect">
+            <a:avLst/>
+          </a:prstGeom>
+          <a:noFill/>
+        </p:spPr>
+        <p:txBody>
+          <a:bodyPr wrap="none" rtlCol="0">
+            <a:spAutoFit/>
+          </a:bodyPr>
+          <a:lstStyle/>
+          <a:p>
+            <a:r>
+              <a:rPr lang="fr-CH" dirty="0"/>
+              <a:t>16</a:t>
+            </a:r>
+          </a:p>
+        </p:txBody>
+      </p:sp>
+      <p:sp>
+        <p:nvSpPr>
+          <p:cNvPr id="35" name="ZoneTexte 11">
+            <a:extLst>
+              <a:ext uri="{FF2B5EF4-FFF2-40B4-BE49-F238E27FC236}">
+                <a16:creationId xmlns:a16="http://schemas.microsoft.com/office/drawing/2014/main" id="{70A3C2F8-9288-83CB-C914-6D886E4B693C}"/>
+              </a:ext>
+            </a:extLst>
+          </p:cNvPr>
+          <p:cNvSpPr txBox="1"/>
+          <p:nvPr/>
+        </p:nvSpPr>
+        <p:spPr>
+          <a:xfrm>
+            <a:off x="5851477" y="4463644"/>
+            <a:ext cx="418704" cy="369332"/>
+          </a:xfrm>
+          <a:prstGeom prst="rect">
+            <a:avLst/>
+          </a:prstGeom>
+          <a:noFill/>
+        </p:spPr>
+        <p:txBody>
+          <a:bodyPr wrap="none" rtlCol="0">
+            <a:spAutoFit/>
+          </a:bodyPr>
+          <a:lstStyle/>
+          <a:p>
+            <a:r>
+              <a:rPr lang="fr-CH" dirty="0"/>
+              <a:t>12</a:t>
+            </a:r>
+          </a:p>
+        </p:txBody>
+      </p:sp>
+      <p:sp>
+        <p:nvSpPr>
+          <p:cNvPr id="37" name="Rectangle 36">
+            <a:extLst>
+              <a:ext uri="{FF2B5EF4-FFF2-40B4-BE49-F238E27FC236}">
+                <a16:creationId xmlns:a16="http://schemas.microsoft.com/office/drawing/2014/main" id="{98598174-6F7A-2BDC-BCA0-EA228FD3F5C1}"/>
+              </a:ext>
+            </a:extLst>
+          </p:cNvPr>
+          <p:cNvSpPr/>
+          <p:nvPr/>
+        </p:nvSpPr>
+        <p:spPr>
+          <a:xfrm>
+            <a:off x="1233412" y="142872"/>
+            <a:ext cx="2284549" cy="3148614"/>
+          </a:xfrm>
+          <a:prstGeom prst="rect">
+            <a:avLst/>
+          </a:prstGeom>
+          <a:noFill/>
+          <a:ln w="19050" cap="flat" cmpd="sng" algn="ctr">
+            <a:solidFill>
+              <a:srgbClr val="FF0000"/>
+            </a:solidFill>
+            <a:prstDash val="solid"/>
+            <a:round/>
+            <a:headEnd type="none" w="med" len="med"/>
+            <a:tailEnd type="none" w="med" len="med"/>
+          </a:ln>
+        </p:spPr>
+        <p:style>
+          <a:lnRef idx="0">
+            <a:scrgbClr r="0" g="0" b="0"/>
+          </a:lnRef>
+          <a:fillRef idx="0">
+            <a:scrgbClr r="0" g="0" b="0"/>
+          </a:fillRef>
+          <a:effectRef idx="0">
+            <a:scrgbClr r="0" g="0" b="0"/>
+          </a:effectRef>
+          <a:fontRef idx="minor">
+            <a:schemeClr val="accent6"/>
+          </a:fontRef>
+        </p:style>
+        <p:txBody>
+          <a:bodyPr rtlCol="0" anchor="ctr"/>
+          <a:lstStyle/>
+          <a:p>
+            <a:pPr algn="ctr"/>
+            <a:endParaRPr lang="en-US"/>
+          </a:p>
+        </p:txBody>
+      </p:sp>
+      <p:sp>
+        <p:nvSpPr>
+          <p:cNvPr id="39" name="TextBox 38">
+            <a:extLst>
+              <a:ext uri="{FF2B5EF4-FFF2-40B4-BE49-F238E27FC236}">
+                <a16:creationId xmlns:a16="http://schemas.microsoft.com/office/drawing/2014/main" id="{42A7ADA8-9226-8385-2C38-205390C3AC54}"/>
+              </a:ext>
+            </a:extLst>
+          </p:cNvPr>
+          <p:cNvSpPr txBox="1"/>
+          <p:nvPr/>
+        </p:nvSpPr>
+        <p:spPr>
+          <a:xfrm>
+            <a:off x="892328" y="114223"/>
+            <a:ext cx="317716" cy="369332"/>
+          </a:xfrm>
+          <a:prstGeom prst="rect">
+            <a:avLst/>
+          </a:prstGeom>
+          <a:noFill/>
+        </p:spPr>
+        <p:txBody>
+          <a:bodyPr wrap="none" rtlCol="0">
+            <a:spAutoFit/>
+          </a:bodyPr>
+          <a:lstStyle/>
+          <a:p>
+            <a:r>
+              <a:rPr lang="en-US" dirty="0">
+                <a:solidFill>
+                  <a:srgbClr val="FF0000"/>
+                </a:solidFill>
+              </a:rPr>
+              <a:t>A</a:t>
+            </a:r>
+          </a:p>
+        </p:txBody>
+      </p:sp>
+      <p:sp>
+        <p:nvSpPr>
+          <p:cNvPr id="41" name="Rectangle 40">
+            <a:extLst>
+              <a:ext uri="{FF2B5EF4-FFF2-40B4-BE49-F238E27FC236}">
+                <a16:creationId xmlns:a16="http://schemas.microsoft.com/office/drawing/2014/main" id="{42002A65-A493-EE3C-6DC4-8EA584D6F878}"/>
+              </a:ext>
+            </a:extLst>
+          </p:cNvPr>
+          <p:cNvSpPr/>
+          <p:nvPr/>
+        </p:nvSpPr>
+        <p:spPr>
+          <a:xfrm>
+            <a:off x="3537408" y="142873"/>
+            <a:ext cx="2507792" cy="3148612"/>
+          </a:xfrm>
+          <a:prstGeom prst="rect">
+            <a:avLst/>
+          </a:prstGeom>
+          <a:noFill/>
+          <a:ln w="19050">
+            <a:solidFill>
+              <a:schemeClr val="accent1">
+                <a:lumMod val="75000"/>
+              </a:schemeClr>
+            </a:solidFill>
+          </a:ln>
+        </p:spPr>
+        <p:style>
+          <a:lnRef idx="2">
+            <a:schemeClr val="accent1">
+              <a:shade val="50000"/>
+            </a:schemeClr>
+          </a:lnRef>
+          <a:fillRef idx="1">
+            <a:schemeClr val="accent1"/>
+          </a:fillRef>
+          <a:effectRef idx="0">
+            <a:schemeClr val="accent1"/>
+          </a:effectRef>
+          <a:fontRef idx="minor">
+            <a:schemeClr val="lt1"/>
+          </a:fontRef>
+        </p:style>
+        <p:txBody>
+          <a:bodyPr rtlCol="0" anchor="ctr"/>
+          <a:lstStyle/>
+          <a:p>
+            <a:pPr algn="ctr"/>
+            <a:endParaRPr lang="fr-CH"/>
+          </a:p>
+        </p:txBody>
+      </p:sp>
+      <p:sp>
+        <p:nvSpPr>
+          <p:cNvPr id="43" name="Rectangle 42">
+            <a:extLst>
+              <a:ext uri="{FF2B5EF4-FFF2-40B4-BE49-F238E27FC236}">
+                <a16:creationId xmlns:a16="http://schemas.microsoft.com/office/drawing/2014/main" id="{85E1F3B9-6DA6-C2D7-D10B-00B58622A4D0}"/>
+              </a:ext>
+            </a:extLst>
+          </p:cNvPr>
+          <p:cNvSpPr/>
+          <p:nvPr/>
+        </p:nvSpPr>
+        <p:spPr>
+          <a:xfrm>
+            <a:off x="3403992" y="3459597"/>
+            <a:ext cx="2958708" cy="2930185"/>
+          </a:xfrm>
+          <a:prstGeom prst="rect">
+            <a:avLst/>
+          </a:prstGeom>
+          <a:noFill/>
+          <a:ln w="19050">
+            <a:solidFill>
+              <a:schemeClr val="accent3">
+                <a:lumMod val="75000"/>
+              </a:schemeClr>
+            </a:solidFill>
+          </a:ln>
+        </p:spPr>
+        <p:style>
+          <a:lnRef idx="2">
+            <a:schemeClr val="accent1">
+              <a:shade val="50000"/>
+            </a:schemeClr>
+          </a:lnRef>
+          <a:fillRef idx="1">
+            <a:schemeClr val="accent1"/>
+          </a:fillRef>
+          <a:effectRef idx="0">
+            <a:schemeClr val="accent1"/>
+          </a:effectRef>
+          <a:fontRef idx="minor">
+            <a:schemeClr val="lt1"/>
+          </a:fontRef>
+        </p:style>
+        <p:txBody>
+          <a:bodyPr rtlCol="0" anchor="ctr"/>
+          <a:lstStyle/>
+          <a:p>
+            <a:pPr algn="ctr"/>
+            <a:endParaRPr lang="fr-CH"/>
+          </a:p>
+        </p:txBody>
+      </p:sp>
+      <p:sp>
+        <p:nvSpPr>
+          <p:cNvPr id="45" name="Rectangle 44">
+            <a:extLst>
+              <a:ext uri="{FF2B5EF4-FFF2-40B4-BE49-F238E27FC236}">
+                <a16:creationId xmlns:a16="http://schemas.microsoft.com/office/drawing/2014/main" id="{9AAF8E03-C05A-96A2-EA2C-EC6F59DF8C97}"/>
+              </a:ext>
+            </a:extLst>
+          </p:cNvPr>
+          <p:cNvSpPr/>
+          <p:nvPr/>
+        </p:nvSpPr>
+        <p:spPr>
+          <a:xfrm>
+            <a:off x="6069512" y="142872"/>
+            <a:ext cx="1893020" cy="3148613"/>
+          </a:xfrm>
+          <a:prstGeom prst="rect">
+            <a:avLst/>
+          </a:prstGeom>
+          <a:noFill/>
+          <a:ln w="19050">
+            <a:solidFill>
+              <a:schemeClr val="accent2">
+                <a:lumMod val="75000"/>
+              </a:schemeClr>
+            </a:solidFill>
+          </a:ln>
+        </p:spPr>
+        <p:style>
+          <a:lnRef idx="2">
+            <a:schemeClr val="accent1">
+              <a:shade val="50000"/>
+            </a:schemeClr>
+          </a:lnRef>
+          <a:fillRef idx="1">
+            <a:schemeClr val="accent1"/>
+          </a:fillRef>
+          <a:effectRef idx="0">
+            <a:schemeClr val="accent1"/>
+          </a:effectRef>
+          <a:fontRef idx="minor">
+            <a:schemeClr val="lt1"/>
+          </a:fontRef>
+        </p:style>
+        <p:txBody>
+          <a:bodyPr rtlCol="0" anchor="ctr"/>
+          <a:lstStyle/>
+          <a:p>
+            <a:pPr algn="ctr"/>
+            <a:endParaRPr lang="fr-CH"/>
+          </a:p>
+        </p:txBody>
+      </p:sp>
+      <p:sp>
+        <p:nvSpPr>
+          <p:cNvPr id="47" name="TextBox 46">
+            <a:extLst>
+              <a:ext uri="{FF2B5EF4-FFF2-40B4-BE49-F238E27FC236}">
+                <a16:creationId xmlns:a16="http://schemas.microsoft.com/office/drawing/2014/main" id="{07AD5F7C-C208-FAE3-811C-27865D586989}"/>
+              </a:ext>
+            </a:extLst>
+          </p:cNvPr>
+          <p:cNvSpPr txBox="1"/>
+          <p:nvPr/>
+        </p:nvSpPr>
+        <p:spPr>
+          <a:xfrm>
+            <a:off x="3147033" y="3357979"/>
+            <a:ext cx="317716" cy="369332"/>
+          </a:xfrm>
+          <a:prstGeom prst="rect">
+            <a:avLst/>
+          </a:prstGeom>
+          <a:noFill/>
+        </p:spPr>
+        <p:txBody>
+          <a:bodyPr wrap="none" rtlCol="0">
+            <a:spAutoFit/>
+          </a:bodyPr>
+          <a:lstStyle/>
+          <a:p>
+            <a:r>
+              <a:rPr lang="en-US" dirty="0">
+                <a:solidFill>
+                  <a:schemeClr val="accent3">
+                    <a:lumMod val="75000"/>
+                  </a:schemeClr>
+                </a:solidFill>
+              </a:rPr>
+              <a:t>C</a:t>
+            </a:r>
+          </a:p>
+        </p:txBody>
+      </p:sp>
+      <p:sp>
+        <p:nvSpPr>
+          <p:cNvPr id="49" name="TextBox 48">
+            <a:extLst>
+              <a:ext uri="{FF2B5EF4-FFF2-40B4-BE49-F238E27FC236}">
+                <a16:creationId xmlns:a16="http://schemas.microsoft.com/office/drawing/2014/main" id="{7DDE5521-2696-96F4-90C1-8E91677F7B6F}"/>
+              </a:ext>
+            </a:extLst>
+          </p:cNvPr>
+          <p:cNvSpPr txBox="1"/>
+          <p:nvPr/>
+        </p:nvSpPr>
+        <p:spPr>
+          <a:xfrm>
+            <a:off x="7962531" y="104837"/>
+            <a:ext cx="327334" cy="369332"/>
+          </a:xfrm>
+          <a:prstGeom prst="rect">
+            <a:avLst/>
+          </a:prstGeom>
+          <a:noFill/>
+        </p:spPr>
+        <p:txBody>
+          <a:bodyPr wrap="none" rtlCol="0">
+            <a:spAutoFit/>
+          </a:bodyPr>
+          <a:lstStyle/>
+          <a:p>
+            <a:r>
+              <a:rPr lang="en-US" dirty="0">
+                <a:solidFill>
+                  <a:schemeClr val="accent2">
+                    <a:lumMod val="75000"/>
+                  </a:schemeClr>
+                </a:solidFill>
+              </a:rPr>
+              <a:t>D</a:t>
+            </a:r>
+          </a:p>
+        </p:txBody>
+      </p:sp>
+      <p:sp>
+        <p:nvSpPr>
+          <p:cNvPr id="51" name="TextBox 50">
+            <a:extLst>
+              <a:ext uri="{FF2B5EF4-FFF2-40B4-BE49-F238E27FC236}">
+                <a16:creationId xmlns:a16="http://schemas.microsoft.com/office/drawing/2014/main" id="{73414055-F9F0-FBC2-6216-D9C4C756514C}"/>
+              </a:ext>
+            </a:extLst>
+          </p:cNvPr>
+          <p:cNvSpPr txBox="1"/>
+          <p:nvPr/>
+        </p:nvSpPr>
+        <p:spPr>
+          <a:xfrm>
+            <a:off x="3537407" y="57986"/>
+            <a:ext cx="317716" cy="369332"/>
+          </a:xfrm>
+          <a:prstGeom prst="rect">
+            <a:avLst/>
+          </a:prstGeom>
+          <a:noFill/>
+        </p:spPr>
+        <p:txBody>
+          <a:bodyPr wrap="none" rtlCol="0">
+            <a:spAutoFit/>
+          </a:bodyPr>
+          <a:lstStyle/>
+          <a:p>
+            <a:r>
+              <a:rPr lang="en-US" dirty="0">
+                <a:solidFill>
+                  <a:schemeClr val="accent5">
+                    <a:lumMod val="75000"/>
+                  </a:schemeClr>
+                </a:solidFill>
+              </a:rPr>
+              <a:t>B</a:t>
             </a:r>
           </a:p>
         </p:txBody>

</xml_diff>

<commit_message>
Update manuel Statistics module
</commit_message>
<xml_diff>
--- a/Manuels/picture_EEGpal_manuals.pptx
+++ b/Manuels/picture_EEGpal_manuals.pptx
@@ -319,7 +319,7 @@
           <a:p>
             <a:fld id="{AE28F081-F961-4F1D-B0FD-EEC618487470}" type="datetimeFigureOut">
               <a:rPr lang="en-US" smtClean="0"/>
-              <a:t>9/13/2026</a:t>
+              <a:t>9/14/2026</a:t>
             </a:fld>
             <a:endParaRPr lang="en-US"/>
           </a:p>
@@ -851,7 +851,7 @@
           <a:p>
             <a:fld id="{BCB0654D-2F9E-40DC-B910-8F58A623289D}" type="datetimeFigureOut">
               <a:rPr lang="fr-CH" smtClean="0"/>
-              <a:t>13.09.2026</a:t>
+              <a:t>14.09.2026</a:t>
             </a:fld>
             <a:endParaRPr lang="fr-CH"/>
           </a:p>
@@ -1021,7 +1021,7 @@
           <a:p>
             <a:fld id="{BCB0654D-2F9E-40DC-B910-8F58A623289D}" type="datetimeFigureOut">
               <a:rPr lang="fr-CH" smtClean="0"/>
-              <a:t>13.09.2026</a:t>
+              <a:t>14.09.2026</a:t>
             </a:fld>
             <a:endParaRPr lang="fr-CH"/>
           </a:p>
@@ -1201,7 +1201,7 @@
           <a:p>
             <a:fld id="{BCB0654D-2F9E-40DC-B910-8F58A623289D}" type="datetimeFigureOut">
               <a:rPr lang="fr-CH" smtClean="0"/>
-              <a:t>13.09.2026</a:t>
+              <a:t>14.09.2026</a:t>
             </a:fld>
             <a:endParaRPr lang="fr-CH"/>
           </a:p>
@@ -1371,7 +1371,7 @@
           <a:p>
             <a:fld id="{BCB0654D-2F9E-40DC-B910-8F58A623289D}" type="datetimeFigureOut">
               <a:rPr lang="fr-CH" smtClean="0"/>
-              <a:t>13.09.2026</a:t>
+              <a:t>14.09.2026</a:t>
             </a:fld>
             <a:endParaRPr lang="fr-CH"/>
           </a:p>
@@ -1617,7 +1617,7 @@
           <a:p>
             <a:fld id="{BCB0654D-2F9E-40DC-B910-8F58A623289D}" type="datetimeFigureOut">
               <a:rPr lang="fr-CH" smtClean="0"/>
-              <a:t>13.09.2026</a:t>
+              <a:t>14.09.2026</a:t>
             </a:fld>
             <a:endParaRPr lang="fr-CH"/>
           </a:p>
@@ -1905,7 +1905,7 @@
           <a:p>
             <a:fld id="{BCB0654D-2F9E-40DC-B910-8F58A623289D}" type="datetimeFigureOut">
               <a:rPr lang="fr-CH" smtClean="0"/>
-              <a:t>13.09.2026</a:t>
+              <a:t>14.09.2026</a:t>
             </a:fld>
             <a:endParaRPr lang="fr-CH"/>
           </a:p>
@@ -2327,7 +2327,7 @@
           <a:p>
             <a:fld id="{BCB0654D-2F9E-40DC-B910-8F58A623289D}" type="datetimeFigureOut">
               <a:rPr lang="fr-CH" smtClean="0"/>
-              <a:t>13.09.2026</a:t>
+              <a:t>14.09.2026</a:t>
             </a:fld>
             <a:endParaRPr lang="fr-CH"/>
           </a:p>
@@ -2445,7 +2445,7 @@
           <a:p>
             <a:fld id="{BCB0654D-2F9E-40DC-B910-8F58A623289D}" type="datetimeFigureOut">
               <a:rPr lang="fr-CH" smtClean="0"/>
-              <a:t>13.09.2026</a:t>
+              <a:t>14.09.2026</a:t>
             </a:fld>
             <a:endParaRPr lang="fr-CH"/>
           </a:p>
@@ -2540,7 +2540,7 @@
           <a:p>
             <a:fld id="{BCB0654D-2F9E-40DC-B910-8F58A623289D}" type="datetimeFigureOut">
               <a:rPr lang="fr-CH" smtClean="0"/>
-              <a:t>13.09.2026</a:t>
+              <a:t>14.09.2026</a:t>
             </a:fld>
             <a:endParaRPr lang="fr-CH"/>
           </a:p>
@@ -2817,7 +2817,7 @@
           <a:p>
             <a:fld id="{BCB0654D-2F9E-40DC-B910-8F58A623289D}" type="datetimeFigureOut">
               <a:rPr lang="fr-CH" smtClean="0"/>
-              <a:t>13.09.2026</a:t>
+              <a:t>14.09.2026</a:t>
             </a:fld>
             <a:endParaRPr lang="fr-CH"/>
           </a:p>
@@ -3070,7 +3070,7 @@
           <a:p>
             <a:fld id="{BCB0654D-2F9E-40DC-B910-8F58A623289D}" type="datetimeFigureOut">
               <a:rPr lang="fr-CH" smtClean="0"/>
-              <a:t>13.09.2026</a:t>
+              <a:t>14.09.2026</a:t>
             </a:fld>
             <a:endParaRPr lang="fr-CH"/>
           </a:p>
@@ -3283,7 +3283,7 @@
           <a:p>
             <a:fld id="{BCB0654D-2F9E-40DC-B910-8F58A623289D}" type="datetimeFigureOut">
               <a:rPr lang="fr-CH" smtClean="0"/>
-              <a:t>13.09.2026</a:t>
+              <a:t>14.09.2026</a:t>
             </a:fld>
             <a:endParaRPr lang="fr-CH"/>
           </a:p>
@@ -14088,7 +14088,7 @@
             </a:r>
             <a:r>
               <a:rPr lang="fr-CH" dirty="0"/>
-              <a:t>7</a:t>
+              <a:t>6</a:t>
             </a:r>
           </a:p>
         </p:txBody>
@@ -14127,7 +14127,7 @@
             </a:r>
             <a:r>
               <a:rPr lang="fr-CH" dirty="0"/>
-              <a:t>9</a:t>
+              <a:t>8</a:t>
             </a:r>
           </a:p>
         </p:txBody>
@@ -14162,7 +14162,7 @@
           <a:p>
             <a:r>
               <a:rPr lang="fr-FR" dirty="0"/>
-              <a:t>20</a:t>
+              <a:t>19</a:t>
             </a:r>
             <a:endParaRPr lang="fr-CH" dirty="0"/>
           </a:p>
@@ -14227,8 +14227,8 @@
           <a:lstStyle/>
           <a:p>
             <a:r>
-              <a:rPr lang="fr-FR" dirty="0"/>
-              <a:t>21</a:t>
+              <a:rPr lang="fr-FR"/>
+              <a:t>20</a:t>
             </a:r>
             <a:endParaRPr lang="fr-CH" dirty="0"/>
           </a:p>
@@ -14295,12 +14295,9 @@
           <a:p>
             <a:r>
               <a:rPr lang="fr-FR" dirty="0"/>
-              <a:t>1</a:t>
-            </a:r>
-            <a:r>
-              <a:rPr lang="fr-CH" dirty="0"/>
-              <a:t>8</a:t>
-            </a:r>
+              <a:t>17</a:t>
+            </a:r>
+            <a:endParaRPr lang="fr-CH" dirty="0"/>
           </a:p>
         </p:txBody>
       </p:sp>
@@ -14449,7 +14446,7 @@
           <a:p>
             <a:r>
               <a:rPr lang="fr-CH" dirty="0"/>
-              <a:t>13</a:t>
+              <a:t>12</a:t>
             </a:r>
           </a:p>
         </p:txBody>
@@ -14484,7 +14481,7 @@
           <a:p>
             <a:r>
               <a:rPr lang="fr-CH" dirty="0"/>
-              <a:t>14</a:t>
+              <a:t>13</a:t>
             </a:r>
           </a:p>
         </p:txBody>
@@ -14519,7 +14516,7 @@
           <a:p>
             <a:r>
               <a:rPr lang="fr-CH" dirty="0"/>
-              <a:t>15</a:t>
+              <a:t>14</a:t>
             </a:r>
           </a:p>
         </p:txBody>
@@ -14554,7 +14551,7 @@
           <a:p>
             <a:r>
               <a:rPr lang="fr-CH" dirty="0"/>
-              <a:t>16</a:t>
+              <a:t>15</a:t>
             </a:r>
           </a:p>
         </p:txBody>

</xml_diff>